<commit_message>
feat(templates): diversify promotion image references
</commit_message>
<xml_diff>
--- a/skills/presentation-template-library/skills/artifact-template-noir-field-pictorial/assets/reference.pptx
+++ b/skills/presentation-template-library/skills/artifact-template-noir-field-pictorial/assets/reference.pptx
@@ -236,13 +236,13 @@
             <a:avLst/>
           </a:prstGeom>
           <a:solidFill xmlns:a="http://schemas.openxmlformats.org/drawingml/2006/main">
-            <a:srgbClr val="F2F0EA">
+            <a:srgbClr val="111214">
               <a:alpha val="84000"/>
             </a:srgbClr>
           </a:solidFill>
           <a:ln xmlns:a="http://schemas.openxmlformats.org/drawingml/2006/main" w="0">
             <a:solidFill>
-              <a:srgbClr val="F2F0EA"/>
+              <a:srgbClr val="111214"/>
             </a:solidFill>
             <a:prstDash val="solid"/>
           </a:ln>
@@ -322,7 +322,7 @@
             <a:r>
               <a:rPr lang="en-US" sz="3900" b="1">
                 <a:solidFill>
-                  <a:srgbClr val="FFFFFF"/>
+                  <a:srgbClr val="F2F0EA"/>
                 </a:solidFill>
                 <a:latin typeface="Inter"/>
                 <a:ea typeface="Inter"/>
@@ -359,7 +359,7 @@
             <a:r>
               <a:rPr lang="en-US" sz="1650">
                 <a:solidFill>
-                  <a:srgbClr val="F0F2F2"/>
+                  <a:srgbClr val="F2F0EA"/>
                 </a:solidFill>
                 <a:latin typeface="Inter"/>
                 <a:ea typeface="Inter"/>
@@ -430,7 +430,7 @@
             <a:r>
               <a:rPr lang="en-US" sz="1950" b="1">
                 <a:solidFill>
-                  <a:srgbClr val="FFFFFF"/>
+                  <a:srgbClr val="F2F0EA"/>
                 </a:solidFill>
                 <a:latin typeface="Inter"/>
                 <a:ea typeface="Inter"/>
@@ -467,7 +467,7 @@
             <a:r>
               <a:rPr lang="en-US" sz="1050">
                 <a:solidFill>
-                  <a:srgbClr val="F0F2F2"/>
+                  <a:srgbClr val="F2F0EA"/>
                 </a:solidFill>
                 <a:latin typeface="Inter"/>
                 <a:ea typeface="Inter"/>
@@ -505,7 +505,7 @@
             <a:r>
               <a:rPr lang="en-US" sz="1050">
                 <a:solidFill>
-                  <a:srgbClr val="F0F2F2"/>
+                  <a:srgbClr val="F2F0EA"/>
                 </a:solidFill>
                 <a:latin typeface="Inter"/>
                 <a:ea typeface="Inter"/>
@@ -2197,7 +2197,7 @@
           <p:nvPr/>
         </p:nvPicPr>
         <p:blipFill>
-          <a:blip xmlns:r="http://schemas.openxmlformats.org/officeDocument/2006/relationships" xmlns:a="http://schemas.openxmlformats.org/drawingml/2006/main" r:embed="rIdOfficeKitImage9df32179333a9f35_1"/>
+          <a:blip xmlns:r="http://schemas.openxmlformats.org/officeDocument/2006/relationships" xmlns:a="http://schemas.openxmlformats.org/drawingml/2006/main" r:embed="rIdOfficeKitImage13db13f70d7843cc_1"/>
           <a:srcRect xmlns:a="http://schemas.openxmlformats.org/drawingml/2006/main" l="0" t="39326" r="0" b="39326"/>
           <a:stretch xmlns:a="http://schemas.openxmlformats.org/drawingml/2006/main">
             <a:fillRect/>
@@ -3120,8 +3120,8 @@
           <p:nvPr/>
         </p:nvPicPr>
         <p:blipFill>
-          <a:blip xmlns:r="http://schemas.openxmlformats.org/officeDocument/2006/relationships" xmlns:a="http://schemas.openxmlformats.org/drawingml/2006/main" r:embed="rIdOfficeKitImagebdd32fb5cfa65986_1"/>
-          <a:srcRect xmlns:a="http://schemas.openxmlformats.org/drawingml/2006/main" l="0" t="47258" r="0" b="47258"/>
+          <a:blip xmlns:r="http://schemas.openxmlformats.org/officeDocument/2006/relationships" xmlns:a="http://schemas.openxmlformats.org/drawingml/2006/main" r:embed="rIdOfficeKitImagee4bd683f73b7a543_1"/>
+          <a:srcRect xmlns:a="http://schemas.openxmlformats.org/drawingml/2006/main" l="0" t="47256" r="0" b="47256"/>
           <a:stretch xmlns:a="http://schemas.openxmlformats.org/drawingml/2006/main">
             <a:fillRect/>
           </a:stretch>
@@ -3332,8 +3332,8 @@
           <p:nvPr/>
         </p:nvPicPr>
         <p:blipFill>
-          <a:blip xmlns:r="http://schemas.openxmlformats.org/officeDocument/2006/relationships" xmlns:a="http://schemas.openxmlformats.org/drawingml/2006/main" r:embed="rIdOfficeKitImage8fbc298f8d1b7a3c_1"/>
-          <a:srcRect xmlns:a="http://schemas.openxmlformats.org/drawingml/2006/main" l="0" t="31971" r="0" b="31971"/>
+          <a:blip xmlns:r="http://schemas.openxmlformats.org/officeDocument/2006/relationships" xmlns:a="http://schemas.openxmlformats.org/drawingml/2006/main" r:embed="rIdOfficeKitImaged3d6b9bbc9872adc_1"/>
+          <a:srcRect xmlns:a="http://schemas.openxmlformats.org/drawingml/2006/main" l="0" t="31962" r="0" b="31962"/>
           <a:stretch xmlns:a="http://schemas.openxmlformats.org/drawingml/2006/main">
             <a:fillRect/>
           </a:stretch>
@@ -3361,8 +3361,8 @@
           <p:nvPr/>
         </p:nvPicPr>
         <p:blipFill>
-          <a:blip xmlns:r="http://schemas.openxmlformats.org/officeDocument/2006/relationships" xmlns:a="http://schemas.openxmlformats.org/drawingml/2006/main" r:embed="rIdOfficeKitImage33b8c33a8fc3d613_1"/>
-          <a:srcRect xmlns:a="http://schemas.openxmlformats.org/drawingml/2006/main" l="0" t="32347" r="0" b="32347"/>
+          <a:blip xmlns:r="http://schemas.openxmlformats.org/officeDocument/2006/relationships" xmlns:a="http://schemas.openxmlformats.org/drawingml/2006/main" r:embed="rIdOfficeKitImage2f5be6b798f5ce32_1"/>
+          <a:srcRect xmlns:a="http://schemas.openxmlformats.org/drawingml/2006/main" l="0" t="32338" r="0" b="32338"/>
           <a:stretch xmlns:a="http://schemas.openxmlformats.org/drawingml/2006/main">
             <a:fillRect/>
           </a:stretch>
@@ -3390,8 +3390,8 @@
           <p:nvPr/>
         </p:nvPicPr>
         <p:blipFill>
-          <a:blip xmlns:r="http://schemas.openxmlformats.org/officeDocument/2006/relationships" xmlns:a="http://schemas.openxmlformats.org/drawingml/2006/main" r:embed="rIdOfficeKitImage7790b68b5d8fcd92_1"/>
-          <a:srcRect xmlns:a="http://schemas.openxmlformats.org/drawingml/2006/main" l="0" t="32347" r="0" b="32347"/>
+          <a:blip xmlns:r="http://schemas.openxmlformats.org/officeDocument/2006/relationships" xmlns:a="http://schemas.openxmlformats.org/drawingml/2006/main" r:embed="rIdOfficeKitImagec237998db8bee20d_1"/>
+          <a:srcRect xmlns:a="http://schemas.openxmlformats.org/drawingml/2006/main" l="0" t="32336" r="0" b="32336"/>
           <a:stretch xmlns:a="http://schemas.openxmlformats.org/drawingml/2006/main">
             <a:fillRect/>
           </a:stretch>
@@ -3419,8 +3419,8 @@
           <p:nvPr/>
         </p:nvPicPr>
         <p:blipFill>
-          <a:blip xmlns:r="http://schemas.openxmlformats.org/officeDocument/2006/relationships" xmlns:a="http://schemas.openxmlformats.org/drawingml/2006/main" r:embed="rIdOfficeKitImagea86c6dad26830b61_1"/>
-          <a:srcRect xmlns:a="http://schemas.openxmlformats.org/drawingml/2006/main" l="0" t="32338" r="0" b="32338"/>
+          <a:blip xmlns:r="http://schemas.openxmlformats.org/officeDocument/2006/relationships" xmlns:a="http://schemas.openxmlformats.org/drawingml/2006/main" r:embed="rIdOfficeKitImage083106afebc7d419_1"/>
+          <a:srcRect xmlns:a="http://schemas.openxmlformats.org/drawingml/2006/main" l="0" t="32347" r="0" b="32347"/>
           <a:stretch xmlns:a="http://schemas.openxmlformats.org/drawingml/2006/main">
             <a:fillRect/>
           </a:stretch>

</xml_diff>